<commit_message>
Corrige el enlace del repositorio en el informe y la presentación
La cuenta de GitHub es augustocco.

Co-Authored-By: Claude Opus 5.5 <noreply@anthropic.com>
</commit_message>
<xml_diff>
--- a/docs/presentacion/Presentacion-AulaNube.pptx
+++ b/docs/presentacion/Presentacion-AulaNube.pptx
@@ -118,41 +118,41 @@
   <p:extLst>
     <p:ext uri="{521415D9-36F7-43E2-AB2F-B90AF26B5E84}">
       <p14:sectionLst xmlns:p14="http://schemas.microsoft.com/office/powerpoint/2010/main">
-        <p14:section name="Apertura" id="{4107d312-cba8-8cb4-61d0-53bf74ef60f4}">
+        <p14:section name="Apertura" id="{61ff786f-cc2e-4cda-6fc0-508e8cc50177}">
           <p14:sldIdLst>
             <p14:sldId id="256"/>
           </p14:sldIdLst>
         </p14:section>
-        <p14:section name="Problema y requisitos" id="{953da293-202b-941b-1a32-c4e123cb730c}">
+        <p14:section name="Problema y requisitos" id="{35471ffd-3151-48a0-5e86-8de5d66ab754}">
           <p14:sldIdLst>
             <p14:sldId id="257"/>
             <p14:sldId id="258"/>
           </p14:sldIdLst>
         </p14:section>
-        <p14:section name="Arquitectura" id="{d1b0dcbf-751e-cd18-5093-d820727ee84c}">
+        <p14:section name="Arquitectura" id="{7d72d36e-0529-2b68-1212-3bbf8fe5d1b3}">
           <p14:sldIdLst>
             <p14:sldId id="259"/>
             <p14:sldId id="260"/>
           </p14:sldIdLst>
         </p14:section>
-        <p14:section name="UML" id="{37a82bed-eff3-8602-cf6f-e22485560971}">
+        <p14:section name="UML" id="{ec0ee529-c084-51ea-8f61-a76517788e18}">
           <p14:sldIdLst>
             <p14:sldId id="261"/>
             <p14:sldId id="262"/>
             <p14:sldId id="263"/>
           </p14:sldIdLst>
         </p14:section>
-        <p14:section name="Patrones" id="{42da0242-4924-8780-1248-29b618b74c94}">
+        <p14:section name="Patrones" id="{e3aebe69-cd49-fa78-d07a-b2671f2e12e9}">
           <p14:sldIdLst>
             <p14:sldId id="264"/>
           </p14:sldIdLst>
         </p14:section>
-        <p14:section name="Demostración" id="{eb3c2551-f85f-02a5-5197-6eb2cbcd6f5d}">
+        <p14:section name="Demostración" id="{55f3e5a7-8487-3696-49ed-b117dd27093c}">
           <p14:sldIdLst>
             <p14:sldId id="265"/>
           </p14:sldIdLst>
         </p14:section>
-        <p14:section name="Cierre" id="{c817dd71-8272-bd5c-1e36-1b8df39d2de0}">
+        <p14:section name="Cierre" id="{39d29c23-6d11-5f0e-c7e2-b31b585786e5}">
           <p14:sldIdLst>
             <p14:sldId id="266"/>
             <p14:sldId id="267"/>
@@ -4024,7 +4024,7 @@
                   <a:schemeClr val="accent6"/>
                 </a:solidFill>
               </a:rPr>
-              <a:t>github.com/augustcco/aulanube · aulanube.149-130-191-139.sslip.io</a:t>
+              <a:t>github.com/augustocco/aulanube · aulanube.149-130-191-139.sslip.io</a:t>
             </a:r>
             <a:endParaRPr lang="en-US" sz="1200" dirty="0"/>
           </a:p>

</xml_diff>

<commit_message>
Ajusta la entrega a trabajo individual
Portada del informe con un solo autor y la línea del video, como en los
informes individuales anteriores; presentación y guion en primera persona
del singular; el README y los documentos ya no mencionan un equipo autor.

Co-Authored-By: Claude Opus 5.5 <noreply@anthropic.com>
</commit_message>
<xml_diff>
--- a/docs/presentacion/Presentacion-AulaNube.pptx
+++ b/docs/presentacion/Presentacion-AulaNube.pptx
@@ -118,41 +118,41 @@
   <p:extLst>
     <p:ext uri="{521415D9-36F7-43E2-AB2F-B90AF26B5E84}">
       <p14:sectionLst xmlns:p14="http://schemas.microsoft.com/office/powerpoint/2010/main">
-        <p14:section name="Apertura" id="{61ff786f-cc2e-4cda-6fc0-508e8cc50177}">
+        <p14:section name="Apertura" id="{70f66ebf-6fa0-0b6d-5134-8089e5210faf}">
           <p14:sldIdLst>
             <p14:sldId id="256"/>
           </p14:sldIdLst>
         </p14:section>
-        <p14:section name="Problema y requisitos" id="{35471ffd-3151-48a0-5e86-8de5d66ab754}">
+        <p14:section name="Problema y requisitos" id="{cc82b6dc-8046-d6ed-f5eb-1e4129bf91d5}">
           <p14:sldIdLst>
             <p14:sldId id="257"/>
             <p14:sldId id="258"/>
           </p14:sldIdLst>
         </p14:section>
-        <p14:section name="Arquitectura" id="{7d72d36e-0529-2b68-1212-3bbf8fe5d1b3}">
+        <p14:section name="Arquitectura" id="{1d1f6d82-e534-6516-3cd4-8d2951d580d2}">
           <p14:sldIdLst>
             <p14:sldId id="259"/>
             <p14:sldId id="260"/>
           </p14:sldIdLst>
         </p14:section>
-        <p14:section name="UML" id="{ec0ee529-c084-51ea-8f61-a76517788e18}">
+        <p14:section name="UML" id="{ab882935-b1a6-27da-595b-c83ae380f22b}">
           <p14:sldIdLst>
             <p14:sldId id="261"/>
             <p14:sldId id="262"/>
             <p14:sldId id="263"/>
           </p14:sldIdLst>
         </p14:section>
-        <p14:section name="Patrones" id="{e3aebe69-cd49-fa78-d07a-b2671f2e12e9}">
+        <p14:section name="Patrones" id="{854e86cc-456c-614a-7059-851915a85486}">
           <p14:sldIdLst>
             <p14:sldId id="264"/>
           </p14:sldIdLst>
         </p14:section>
-        <p14:section name="Demostración" id="{55f3e5a7-8487-3696-49ed-b117dd27093c}">
+        <p14:section name="Demostración" id="{e8d2222e-b0f6-2b51-d9a8-ead20cffc692}">
           <p14:sldIdLst>
             <p14:sldId id="265"/>
           </p14:sldIdLst>
         </p14:section>
-        <p14:section name="Cierre" id="{39d29c23-6d11-5f0e-c7e2-b31b585786e5}">
+        <p14:section name="Cierre" id="{3e1658e8-ff7c-d044-551d-469d2725c8a7}">
           <p14:sldIdLst>
             <p14:sldId id="266"/>
             <p14:sldId id="267"/>
@@ -562,8 +562,8 @@
           <a:p>
             <a:r>
               <a:rPr lang="en-US" dirty="0"/>
-              <a:t>[Integrante 1 · 0:00–0:45]
-Buenas. Somos el equipo de AulaNube. En los próximos quince minutos vamos a presentar la arquitectura que diseñamos para CapacitaPro, una empresa que vende capacitación virtual obligatoria a otras empresas: el problema, los requisitos, los diagramas UML, los patrones que elegimos y, al final, el prototipo funcionando en Oracle Cloud.</a:t>
+              <a:t>[0:00–0:45]
+Buenas. Soy Augusto César Cañola Ortiz. En los próximos quince minutos voy a presentar la arquitectura que diseñé para CapacitaPro, una empresa que vende capacitación virtual obligatoria a otras empresas: el problema, los requisitos, los diagramas UML, los patrones que elegí y, al final, el prototipo funcionando en Oracle Cloud.</a:t>
             </a:r>
             <a:endParaRPr lang="en-US" dirty="0"/>
           </a:p>
@@ -651,7 +651,7 @@
           <a:p>
             <a:r>
               <a:rPr lang="en-US" dirty="0"/>
-              <a:t>[Integrante 4 · 10:00–13:00 · DEMOSTRACIÓN]
+              <a:t>[10:00–13:00 · DEMOSTRACIÓN]
 1. Ingresar como Carlos (estudiante de Constructora Los Andes). Abrir «Inducción al SG-SST» (si ya está completo, usar otra cuenta de estudiante, por ejemplo yesenia@andes.demo), marcar las lecciones. Mostrar el aviso «su certificado está en camino», ir a Certificados, descargar el PDF y abrir «Verificar» para mostrar la verificación pública.
 2. Salir e ingresar como Laura (administradora). En Gestión, lanzar una campaña de 200 participantes. Mostrar que respondió al instante e ir a Arquitectura: la cola de «certificados» sube y baja mientras dos trabajadores la procesan. En Certificados, la columna Trabajador muestra qué réplica emitió cada uno.
 3. En una terminal: kubectl -n aulanube scale deploy certificados --replicas=0. Refrescar Certificados tres o cuatro veces: después del tercer fallo responde de inmediato con «circuito abierto». El panel muestra Certificados en rojo y los demás en verde; Cursos sigue funcionando.
@@ -744,8 +744,8 @@
           <a:p>
             <a:r>
               <a:rPr lang="en-US" dirty="0"/>
-              <a:t>[Integrante 1 · 13:00–14:00]
-Volvemos a los escenarios del principio, ahora con números medidos en la nube. Una campaña masiva responde en menos de 200 milisegundos y los 200 certificados se emitieron sin errores. Con el servicio de certificados caído, el gateway responde en 110 milisegundos en lugar de quedarse esperando. No se perdió ningún certificado con el trabajador apagado. Y hay 28 pruebas automatizadas que pasan tanto en x86 como en los nodos ARM.</a:t>
+              <a:t>[13:00–14:00]
+Vuelvo a los escenarios del principio, ahora con números medidos en la nube. Una campaña masiva responde en menos de 200 milisegundos y los 200 certificados se emitieron sin errores. Con el servicio de certificados caído, el gateway responde en 110 milisegundos en lugar de quedarse esperando. No se perdió ningún certificado con el trabajador apagado. Y hay 28 pruebas automatizadas que pasan tanto en x86 como en los nodos ARM.</a:t>
             </a:r>
             <a:endParaRPr lang="en-US" dirty="0"/>
           </a:p>
@@ -833,8 +833,8 @@
           <a:p>
             <a:r>
               <a:rPr lang="en-US" dirty="0"/>
-              <a:t>[Integrante 1 · 14:00–15:00]
-Para cerrar: los problemas de CapacitaPro eran de arquitectura, no de código. Cambiamos la estructura y los síntomas desaparecieron sin optimizar la lógica de negocio. Escribir los requisitos como escenarios medibles nos permitió elegir los patrones con criterio y comprobarlos. Los principios de la unidad se volvieron decisiones concretas. Y aprendimos que la asincronía tiene un costo que hay que hacer explícito.
+              <a:t>[14:00–15:00]
+Para cerrar: los problemas de CapacitaPro eran de arquitectura, no de código. Cambié la estructura y los síntomas desaparecieron sin optimizar la lógica de negocio. Escribir los requisitos como escenarios medibles me permitió elegir los patrones con criterio y comprobarlos. Los principios de la unidad se volvieron decisiones concretas. Y aprendí que la asincronía tiene un costo que hay que hacer explícito.
 El código, el informe y los diagramas están en el repositorio, y la plataforma sigue publicada en la dirección que ven en pantalla. Muchas gracias.</a:t>
             </a:r>
             <a:endParaRPr lang="en-US" dirty="0"/>
@@ -923,7 +923,7 @@
           <a:p>
             <a:r>
               <a:rPr lang="en-US" dirty="0"/>
-              <a:t>[Integrante 1 · 0:45–2:00]
+              <a:t>[0:45–2:00]
 El caso: CapacitaPro tiene 38 clientes y a cada uno le instala su propio WordPress. Eso tuvo tres consecuencias. Primero, cuando una constructora cerró su campaña de trabajo en alturas, 1.100 trabajadores terminaron el curso el mismo día y el servidor se cayó 40 minutos, llevándose a otros siete clientes. Segundo, el certificado y el correo se generan mientras el usuario espera, así que terminar un curso tarda hasta 25 segundos. Tercero, cada actualización se hace 38 veces.
 Lo que pide la gerencia es una plataforma multiempresa que absorba esos picos, que una falla no tumbe todo y que funcione con bajo costo.</a:t>
             </a:r>
@@ -1013,9 +1013,9 @@
           <a:p>
             <a:r>
               <a:rPr lang="en-US" dirty="0"/>
-              <a:t>[Integrante 2 · 2:00–3:15]
-Para el análisis usamos análisis documental del caso, una entrevista simulada donde cada uno representó a un interesado, historias de usuario y priorización MoSCoW. Salieron 14 requisitos funcionales.
-Lo más importante fue escribir los no funcionales como escenarios medibles, no como adjetivos. No decimos «debe ser escalable», decimos: si 150 personas terminan el curso en el mismo minuto, la respuesta tarda menos de un segundo y no se pierde ningún certificado. Estos cuatro escenarios son los que más pesaron en las decisiones de arquitectura y, al final, los vamos a comprobar con mediciones.</a:t>
+              <a:t>[2:00–3:15]
+Para el análisis usé análisis documental del caso, una entrevista simulada con tres interesados, historias de usuario y priorización MoSCoW. Salieron 14 requisitos funcionales.
+Lo más importante fue escribir los no funcionales como escenarios medibles, no como adjetivos. No digo «debe ser escalable», digo: si 150 personas terminan el curso en el mismo minuto, la respuesta tarda menos de un segundo y no se pierde ningún certificado. Estos cuatro escenarios son los que más pesaron en las decisiones de arquitectura y, al final, los voy a comprobar con mediciones.</a:t>
             </a:r>
             <a:endParaRPr lang="en-US" dirty="0"/>
           </a:p>
@@ -1103,9 +1103,9 @@
           <a:p>
             <a:r>
               <a:rPr lang="en-US" dirty="0"/>
-              <a:t>[Integrante 2 · 3:15–4:30]
-Elegimos microservicios con comunicación híbrida. Lo que el estudiante consulta, como el catálogo o su avance, va por REST y responde de inmediato. Lo que puede pasar después, generar el PDF y avisar, va por eventos en Redis Streams.
-Consideramos un monolito modular, que es más simple, pero escala y falla como una sola pieza, y ese es justamente el problema de CapacitaPro. Hay cinco componentes: un API Gateway como única entrada y cuatro servicios —identidad, cursos, certificados y notificaciones—, cada uno con su propia base de datos.</a:t>
+              <a:t>[3:15–4:30]
+Elegí microservicios con comunicación híbrida. Lo que el estudiante consulta, como el catálogo o su avance, va por REST y responde de inmediato. Lo que puede pasar después, generar el PDF y avisar, va por eventos en Redis Streams.
+Consideré un monolito modular, que es más simple, pero escala y falla como una sola pieza, y ese es justamente el problema de CapacitaPro. Hay cinco componentes: un API Gateway como única entrada y cuatro servicios —identidad, cursos, certificados y notificaciones—, cada uno con su propia base de datos.</a:t>
             </a:r>
             <a:endParaRPr lang="en-US" dirty="0"/>
           </a:p>
@@ -1193,8 +1193,8 @@
           <a:p>
             <a:r>
               <a:rPr lang="en-US" dirty="0"/>
-              <a:t>[Integrante 2 · 4:30–5:15]
-Esto conecta con la teoría de la unidad. Alta cohesión: cada servicio hace una sola cosa del dominio. Bajo acoplamiento: ningún servicio llama a otro; cursos solo publica un evento y no sabe quién lo consume, así que mañana podemos agregar facturación sin tocarlo. Y ocultamiento de información, de Parnas: la base de datos de cada servicio es un detalle interno. De hecho, durante el proyecto reorganizamos los flujos de eventos y solo tuvimos que tocar dos servicios.</a:t>
+              <a:t>[4:30–5:15]
+Esto conecta con la teoría de la unidad. Alta cohesión: cada servicio hace una sola cosa del dominio. Bajo acoplamiento: ningún servicio llama a otro; cursos solo publica un evento y no sabe quién lo consume, así que mañana se puede agregar facturación sin tocarlo. Y ocultamiento de información, de Parnas: la base de datos de cada servicio es un detalle interno. De hecho, durante el proyecto reorganicé los flujos de eventos y solo tuve que tocar dos servicios.</a:t>
             </a:r>
             <a:endParaRPr lang="en-US" dirty="0"/>
           </a:p>
@@ -1282,8 +1282,8 @@
           <a:p>
             <a:r>
               <a:rPr lang="en-US" dirty="0"/>
-              <a:t>[Integrante 3 · 5:15–6:30]
-Pasamos a UML. En casos de uso hay cuatro actores: estudiante, administrador de la empresa, un verificador externo sin cuenta y el propio sistema. El detalle clave es que «Emitir certificado» lo dispara un evento, no una persona. Eso nos dijo desde el principio que la emisión debía ser asíncrona.
+              <a:t>[5:15–6:30]
+Paso a UML. En casos de uso hay cuatro actores: estudiante, administrador de la empresa, un verificador externo sin cuenta y el propio sistema. El detalle clave es que «Emitir certificado» lo dispara un evento, no una persona. Eso me indicó desde el principio que la emisión debía ser asíncrona.
 En el diagrama de clases cada paquete es un servicio con su base. Fíjense en que ninguna asociación cruza paquetes: entre servicios solo hay identificadores lógicos o eventos. Y las restricciones de unicidad en certificado y notificación son las que hacen que un evento repetido no genere duplicados.</a:t>
             </a:r>
             <a:endParaRPr lang="en-US" dirty="0"/>
@@ -1372,7 +1372,7 @@
           <a:p>
             <a:r>
               <a:rPr lang="en-US" dirty="0"/>
-              <a:t>[Integrante 3 · 6:30–7:30]
+              <a:t>[6:30–7:30]
 El diagrama de secuencia muestra el escenario que resuelve el problema del caso. Cuando el estudiante marca la última lección, cursos guarda el avance y el evento «curso.completado» en la misma transacción —es el patrón Outbox— y responde enseguida. En segundo plano, un hilo publica el evento en Redis. Los grupos de certificados y notificaciones lo reciben en paralelo; el trabajador genera el PDF y publica a su vez «certificado.emitido», que notificaciones convierte en el aviso. El usuario ya no espera por el PDF ni por el correo.</a:t>
             </a:r>
             <a:endParaRPr lang="en-US" dirty="0"/>
@@ -1461,7 +1461,7 @@
           <a:p>
             <a:r>
               <a:rPr lang="en-US" dirty="0"/>
-              <a:t>[Integrante 3 · 7:30–8:30]
+              <a:t>[7:30–8:30]
 El despliegue: dos máquinas virtuales Ampere A1 de Oracle Cloud en Bogotá, con un clúster K3s, todo dentro de la capa Always Free. Traefik recibe el tráfico HTTPS con certificado de Let's Encrypt. La web y el gateway tienen una réplica en cada nodo, así que si cae una máquina la entrada sigue viva. Certificados escala de 2 a 4 réplicas por CPU. Y las políticas de red solo permiten el camino web, gateway, servicios, datos: un pod que no sea el gateway no puede hablar con los servicios.</a:t>
             </a:r>
             <a:endParaRPr lang="en-US" dirty="0"/>
@@ -1550,9 +1550,9 @@
           <a:p>
             <a:r>
               <a:rPr lang="en-US" dirty="0"/>
-              <a:t>[Integrante 4 · 8:30–10:00]
+              <a:t>[8:30–10:00]
 Cada patrón responde a un escenario. API Gateway: una sola entrada que valida el token y borra cualquier cabecera de identidad que mande el cliente. Database per Service para el desacoplamiento. Publicador-suscriptor con un flujo de Redis por publicador. Outbox para que ningún evento se pierda si Redis falla. Para los cierres de campaña, nivelación de carga con cola más consumidores en competencia: la campaña responde 202 al instante y varias réplicas reparten el trabajo. Circuit breaker: tras tres fallos seguidos el gateway deja de llamar al servicio caído durante 15 segundos. Y un límite de solicitudes por empresa, para que un cliente no acapare la plataforma.
-Descartamos Saga y CQRS porque ningún flujo los necesita, y un service mesh porque no cabe en nodos de una sola OCPU.</a:t>
+Descarté Saga y CQRS porque ningún flujo los necesita, y un service mesh porque no cabe en nodos de una sola OCPU.</a:t>
             </a:r>
             <a:endParaRPr lang="en-US" dirty="0"/>
           </a:p>
@@ -2525,7 +2525,7 @@
                   <a:schemeClr val="bg1"/>
                 </a:solidFill>
               </a:rPr>
-              <a:t>[Integrante 1] (líder) · [Integrante 2] · [Integrante 3] · [Integrante 4]</a:t>
+              <a:t>Augusto César Cañola Ortiz · Docente: [Nombre del docente]</a:t>
             </a:r>
             <a:endParaRPr lang="en-US" sz="1300" dirty="0"/>
           </a:p>

</xml_diff>

<commit_message>
Agrega el enlace del video de YouTube
En la portada del informe, la diapositiva final, el guion y el README.

Co-Authored-By: Claude Opus 5.5 <noreply@anthropic.com>
</commit_message>
<xml_diff>
--- a/docs/presentacion/Presentacion-AulaNube.pptx
+++ b/docs/presentacion/Presentacion-AulaNube.pptx
@@ -118,41 +118,41 @@
   <p:extLst>
     <p:ext uri="{521415D9-36F7-43E2-AB2F-B90AF26B5E84}">
       <p14:sectionLst xmlns:p14="http://schemas.microsoft.com/office/powerpoint/2010/main">
-        <p14:section name="Apertura" id="{70f66ebf-6fa0-0b6d-5134-8089e5210faf}">
+        <p14:section name="Apertura" id="{afa9fc5a-a01f-f41b-98ce-8b1116fed7ef}">
           <p14:sldIdLst>
             <p14:sldId id="256"/>
           </p14:sldIdLst>
         </p14:section>
-        <p14:section name="Problema y requisitos" id="{cc82b6dc-8046-d6ed-f5eb-1e4129bf91d5}">
+        <p14:section name="Problema y requisitos" id="{d4ccb916-964a-0920-2ff4-9874ec33989b}">
           <p14:sldIdLst>
             <p14:sldId id="257"/>
             <p14:sldId id="258"/>
           </p14:sldIdLst>
         </p14:section>
-        <p14:section name="Arquitectura" id="{1d1f6d82-e534-6516-3cd4-8d2951d580d2}">
+        <p14:section name="Arquitectura" id="{bf34831b-562c-848e-512f-17ee0deb6226}">
           <p14:sldIdLst>
             <p14:sldId id="259"/>
             <p14:sldId id="260"/>
           </p14:sldIdLst>
         </p14:section>
-        <p14:section name="UML" id="{ab882935-b1a6-27da-595b-c83ae380f22b}">
+        <p14:section name="UML" id="{a275403f-42f3-2d03-69f3-711c23ad83df}">
           <p14:sldIdLst>
             <p14:sldId id="261"/>
             <p14:sldId id="262"/>
             <p14:sldId id="263"/>
           </p14:sldIdLst>
         </p14:section>
-        <p14:section name="Patrones" id="{854e86cc-456c-614a-7059-851915a85486}">
+        <p14:section name="Patrones" id="{5647148b-6bdf-bfcc-c31f-2c0fe29d4159}">
           <p14:sldIdLst>
             <p14:sldId id="264"/>
           </p14:sldIdLst>
         </p14:section>
-        <p14:section name="Demostración" id="{e8d2222e-b0f6-2b51-d9a8-ead20cffc692}">
+        <p14:section name="Demostración" id="{28d50478-171b-89a0-7428-f158a87350a5}">
           <p14:sldIdLst>
             <p14:sldId id="265"/>
           </p14:sldIdLst>
         </p14:section>
-        <p14:section name="Cierre" id="{3e1658e8-ff7c-d044-551d-469d2725c8a7}">
+        <p14:section name="Cierre" id="{58a67eb4-f5f4-8577-6e14-c8f9c4e36d31}">
           <p14:sldIdLst>
             <p14:sldId id="266"/>
             <p14:sldId id="267"/>
@@ -4024,7 +4024,7 @@
                   <a:schemeClr val="accent6"/>
                 </a:solidFill>
               </a:rPr>
-              <a:t>github.com/augustocco/aulanube · aulanube.149-130-191-139.sslip.io</a:t>
+              <a:t>Video: youtu.be/MIRqI7KDZq0 · github.com/augustocco/aulanube · aulanube.149-130-191-139.sslip.io</a:t>
             </a:r>
             <a:endParaRPr lang="en-US" sz="1200" dirty="0"/>
           </a:p>

</xml_diff>

<commit_message>
Agrega el nombre de la docente
Ing. Leydi Johana Polo Amador, en la portada del informe, la presentación
y la descripción del video.

Co-Authored-By: Claude Opus 5.5 <noreply@anthropic.com>
</commit_message>
<xml_diff>
--- a/docs/presentacion/Presentacion-AulaNube.pptx
+++ b/docs/presentacion/Presentacion-AulaNube.pptx
@@ -118,41 +118,41 @@
   <p:extLst>
     <p:ext uri="{521415D9-36F7-43E2-AB2F-B90AF26B5E84}">
       <p14:sectionLst xmlns:p14="http://schemas.microsoft.com/office/powerpoint/2010/main">
-        <p14:section name="Apertura" id="{afa9fc5a-a01f-f41b-98ce-8b1116fed7ef}">
+        <p14:section name="Apertura" id="{9431a6ea-b8f6-9279-c287-6b8d32b074f0}">
           <p14:sldIdLst>
             <p14:sldId id="256"/>
           </p14:sldIdLst>
         </p14:section>
-        <p14:section name="Problema y requisitos" id="{d4ccb916-964a-0920-2ff4-9874ec33989b}">
+        <p14:section name="Problema y requisitos" id="{1180031b-d26a-0a2d-b335-66e7667465b9}">
           <p14:sldIdLst>
             <p14:sldId id="257"/>
             <p14:sldId id="258"/>
           </p14:sldIdLst>
         </p14:section>
-        <p14:section name="Arquitectura" id="{bf34831b-562c-848e-512f-17ee0deb6226}">
+        <p14:section name="Arquitectura" id="{398eb0f3-80ce-fbd7-ffbf-1472d63d407c}">
           <p14:sldIdLst>
             <p14:sldId id="259"/>
             <p14:sldId id="260"/>
           </p14:sldIdLst>
         </p14:section>
-        <p14:section name="UML" id="{a275403f-42f3-2d03-69f3-711c23ad83df}">
+        <p14:section name="UML" id="{749bd4be-cd6d-1036-b6e5-5d203597292b}">
           <p14:sldIdLst>
             <p14:sldId id="261"/>
             <p14:sldId id="262"/>
             <p14:sldId id="263"/>
           </p14:sldIdLst>
         </p14:section>
-        <p14:section name="Patrones" id="{5647148b-6bdf-bfcc-c31f-2c0fe29d4159}">
+        <p14:section name="Patrones" id="{d0fa0fb6-b23c-e528-fc1a-64a93a6cfa38}">
           <p14:sldIdLst>
             <p14:sldId id="264"/>
           </p14:sldIdLst>
         </p14:section>
-        <p14:section name="Demostración" id="{28d50478-171b-89a0-7428-f158a87350a5}">
+        <p14:section name="Demostración" id="{8cad6ff9-b1bf-96cd-73f1-d31e744f07d2}">
           <p14:sldIdLst>
             <p14:sldId id="265"/>
           </p14:sldIdLst>
         </p14:section>
-        <p14:section name="Cierre" id="{58a67eb4-f5f4-8577-6e14-c8f9c4e36d31}">
+        <p14:section name="Cierre" id="{2f201a09-0aeb-a117-bc41-c5ad179176c5}">
           <p14:sldIdLst>
             <p14:sldId id="266"/>
             <p14:sldId id="267"/>
@@ -2525,7 +2525,7 @@
                   <a:schemeClr val="bg1"/>
                 </a:solidFill>
               </a:rPr>
-              <a:t>Augusto César Cañola Ortiz · Docente: [Nombre del docente]</a:t>
+              <a:t>Augusto César Cañola Ortiz · Docente: Ing. Leydi Johana Polo Amador</a:t>
             </a:r>
             <a:endParaRPr lang="en-US" sz="1300" dirty="0"/>
           </a:p>

</xml_diff>